<commit_message>
Final pass: baselines labels seed vs current policy correctly; README file map, reproduce steps and market sources; deck placeholders filled from gate results; brief status updated
Co-Authored-By: Claude Opus 5.5 <noreply@anthropic.com>
Claude-Session: https://claude.ai/code/session_01JkvGXPDmdhTEYLDAFvks23
</commit_message>
<xml_diff>
--- a/presentation/moonfire-deck.pptx
+++ b/presentation/moonfire-deck.pptx
@@ -9670,6 +9670,10 @@
             <a:prstDash val="solid"/>
           </a:ln>
         </p:spPr>
+        <p:txBody>
+          <a:bodyPr/>
+          <a:p/>
+        </p:txBody>
       </p:sp>
       <p:pic>
         <p:nvPicPr>
@@ -9829,6 +9833,10 @@
             <a:prstDash val="solid"/>
           </a:ln>
         </p:spPr>
+        <p:txBody>
+          <a:bodyPr/>
+          <a:p/>
+        </p:txBody>
       </p:sp>
       <p:pic>
         <p:nvPicPr>
@@ -9988,6 +9996,10 @@
             <a:prstDash val="solid"/>
           </a:ln>
         </p:spPr>
+        <p:txBody>
+          <a:bodyPr/>
+          <a:p/>
+        </p:txBody>
       </p:sp>
       <p:pic>
         <p:nvPicPr>
@@ -10147,6 +10159,10 @@
             <a:prstDash val="solid"/>
           </a:ln>
         </p:spPr>
+        <p:txBody>
+          <a:bodyPr/>
+          <a:p/>
+        </p:txBody>
       </p:sp>
       <p:pic>
         <p:nvPicPr>
@@ -10306,6 +10322,10 @@
             <a:prstDash val="solid"/>
           </a:ln>
         </p:spPr>
+        <p:txBody>
+          <a:bodyPr/>
+          <a:p/>
+        </p:txBody>
       </p:sp>
       <p:pic>
         <p:nvPicPr>
@@ -10465,6 +10485,10 @@
             <a:prstDash val="solid"/>
           </a:ln>
         </p:spPr>
+        <p:txBody>
+          <a:bodyPr/>
+          <a:p/>
+        </p:txBody>
       </p:sp>
       <p:pic>
         <p:nvPicPr>
@@ -10905,7 +10929,7 @@
                   <a:schemeClr val="accent4"/>
                 </a:solidFill>
               </a:rPr>
-              <a:t>[placeholder] experiment count read from loop_log.md at build time; confirm it against the final log</a:t>
+              <a:t>249 experiments logged in loop_log.md, 39 kept; every kept change is a git commit</a:t>
             </a:r>
             <a:endParaRPr lang="en-US" sz="1000" dirty="0"/>
           </a:p>
@@ -12894,7 +12918,7 @@
                           <a:ea typeface="Calibri" pitchFamily="34" charset="-122"/>
                           <a:cs typeface="Calibri" pitchFamily="34" charset="-120"/>
                         </a:rPr>
-                        <a:t>[placeholder] gate.py</a:t>
+                        <a:t>61.6</a:t>
                       </a:r>
                       <a:endParaRPr lang="en-US" sz="950" dirty="0">
                         <a:latin typeface="Calibri" charset="0"/>
@@ -12959,7 +12983,7 @@
                           <a:ea typeface="Calibri" pitchFamily="34" charset="-122"/>
                           <a:cs typeface="Calibri" pitchFamily="34" charset="-120"/>
                         </a:rPr>
-                        <a:t>[placeholder] gate.py</a:t>
+                        <a:t>70.6</a:t>
                       </a:r>
                       <a:endParaRPr lang="en-US" sz="950" dirty="0">
                         <a:latin typeface="Calibri" charset="0"/>
@@ -13024,7 +13048,7 @@
                           <a:ea typeface="Calibri" pitchFamily="34" charset="-122"/>
                           <a:cs typeface="Calibri" pitchFamily="34" charset="-120"/>
                         </a:rPr>
-                        <a:t>[placeholder] gate.py</a:t>
+                        <a:t>46.3</a:t>
                       </a:r>
                       <a:endParaRPr lang="en-US" sz="950" dirty="0">
                         <a:latin typeface="Calibri" charset="0"/>
@@ -13089,7 +13113,7 @@
                           <a:ea typeface="Calibri" pitchFamily="34" charset="-122"/>
                           <a:cs typeface="Calibri" pitchFamily="34" charset="-120"/>
                         </a:rPr>
-                        <a:t>[placeholder] gate.py</a:t>
+                        <a:t>0.45</a:t>
                       </a:r>
                       <a:endParaRPr lang="en-US" sz="950" dirty="0">
                         <a:latin typeface="Calibri" charset="0"/>
@@ -13583,6 +13607,10 @@
             <a:prstDash val="solid"/>
           </a:ln>
         </p:spPr>
+        <p:txBody>
+          <a:bodyPr/>
+          <a:p/>
+        </p:txBody>
       </p:sp>
       <p:sp>
         <p:nvSpPr>
@@ -13719,6 +13747,10 @@
             <a:prstDash val="solid"/>
           </a:ln>
         </p:spPr>
+        <p:txBody>
+          <a:bodyPr/>
+          <a:p/>
+        </p:txBody>
       </p:sp>
       <p:sp>
         <p:nvSpPr>
@@ -13789,7 +13821,7 @@
                 <a:ea typeface="Arial" pitchFamily="34" charset="-122"/>
                 <a:cs typeface="Arial" pitchFamily="34" charset="-120"/>
               </a:rPr>
-              <a:t>£55.1 → [placeholder]</a:t>
+              <a:t>£55.1 → £70.6</a:t>
             </a:r>
             <a:endParaRPr lang="en-US" sz="1400" dirty="0"/>
           </a:p>
@@ -13825,7 +13857,7 @@
                   <a:schemeClr val="tx2"/>
                 </a:solidFill>
               </a:rPr>
-              <a:t>[placeholder] from gate.py; seed is 36.1%</a:t>
+              <a:t>36.1% → 46.3% of perfect, +28%</a:t>
             </a:r>
             <a:endParaRPr lang="en-US" sz="950" dirty="0"/>
           </a:p>
@@ -13855,6 +13887,10 @@
             <a:prstDash val="solid"/>
           </a:ln>
         </p:spPr>
+        <p:txBody>
+          <a:bodyPr/>
+          <a:p/>
+        </p:txBody>
       </p:sp>
       <p:sp>
         <p:nvSpPr>
@@ -14075,58 +14111,6 @@
           </a:p>
         </p:txBody>
       </p:sp>
-      <p:graphicFrame>
-        <p:nvGraphicFramePr>
-          <p:cNvPr id="3" name="Chart 0" descr=""/>
-          <p:cNvGraphicFramePr/>
-          <p:nvPr/>
-        </p:nvGraphicFramePr>
-        <p:xfrm>
-          <a:off x="457200" y="1051560"/>
-          <a:ext cx="6675120" cy="3429000"/>
-        </p:xfrm>
-        <a:graphic xmlns:a="http://schemas.openxmlformats.org/drawingml/2006/main">
-          <a:graphicData uri="http://schemas.openxmlformats.org/drawingml/2006/chart">
-            <c:chart xmlns:c="http://schemas.openxmlformats.org/drawingml/2006/chart" r:id="rId1"/>
-          </a:graphicData>
-        </a:graphic>
-      </p:graphicFrame>
-      <p:sp>
-        <p:nvSpPr>
-          <p:cNvPr id="4" name="placeholder note"/>
-          <p:cNvSpPr txBox="1"/>
-          <p:nvPr/>
-        </p:nvSpPr>
-        <p:spPr>
-          <a:xfrm>
-            <a:off x="457200" y="4498848"/>
-            <a:ext cx="6675120" cy="274320"/>
-          </a:xfrm>
-          <a:prstGeom prst="rect">
-            <a:avLst/>
-          </a:prstGeom>
-          <a:noFill/>
-          <a:ln/>
-        </p:spPr>
-        <p:txBody>
-          <a:bodyPr wrap="square" lIns="0" tIns="0" rIns="0" bIns="0" rtlCol="0" anchor="ctr"/>
-          <a:lstStyle/>
-          <a:p>
-            <a:pPr indent="0" marL="0">
-              <a:buNone/>
-            </a:pPr>
-            <a:r>
-              <a:rPr lang="en-US" sz="1000" i="1" dirty="0">
-                <a:solidFill>
-                  <a:schemeClr val="accent4"/>
-                </a:solidFill>
-              </a:rPr>
-              <a:t>[placeholder] price line only. After gate.py and plot.py run, swap in results/test_week.png (champion charge and discharge marks on the price, plus a state-of-charge panel for champion vs seed).</a:t>
-            </a:r>
-            <a:endParaRPr lang="en-US" sz="1000" dirty="0"/>
-          </a:p>
-        </p:txBody>
-      </p:sp>
       <p:sp>
         <p:nvSpPr>
           <p:cNvPr id="5" name="week legend card"/>
@@ -14375,6 +14359,30 @@
           </a:p>
         </p:txBody>
       </p:sp>
+      <p:pic>
+        <p:nvPicPr>
+          <p:cNvPr id="26" name="Picture 25" descr="test_week.png"/>
+          <p:cNvPicPr>
+            <a:picLocks noChangeAspect="1"/>
+          </p:cNvPicPr>
+          <p:nvPr/>
+        </p:nvPicPr>
+        <p:blipFill>
+          <a:blip r:embed="rId4"/>
+          <a:stretch>
+            <a:fillRect/>
+          </a:stretch>
+        </p:blipFill>
+        <p:spPr>
+          <a:xfrm>
+            <a:off x="457200" y="1051560"/>
+            <a:ext cx="6675120" cy="3640974"/>
+          </a:xfrm>
+          <a:prstGeom prst="rect">
+            <a:avLst/>
+          </a:prstGeom>
+        </p:spPr>
+      </p:pic>
     </p:spTree>
   </p:cSld>
   <p:clrMapOvr>

</xml_diff>

<commit_message>
Make every stated figure match measured values: evaluation under 1 s (not 0.2 s), oracle 16 ms, volatility 1.4-1.7x spread / 1.8-2.3x ceiling (not 2-3x), loop ~30 min, PoP 46%; drop duplicate deck note; align best-asset figure
Co-Authored-By: Claude Opus 5.5 <noreply@anthropic.com>
Claude-Session: https://claude.ai/code/session_01JkvGXPDmdhTEYLDAFvks23
</commit_message>
<xml_diff>
--- a/presentation/moonfire-deck.pptx
+++ b/presentation/moonfire-deck.pptx
@@ -6146,6 +6146,10 @@
             <a:prstDash val="solid"/>
           </a:ln>
         </p:spPr>
+        <p:txBody>
+          <a:bodyPr/>
+          <a:p/>
+        </p:txBody>
       </p:sp>
       <p:sp>
         <p:nvSpPr>
@@ -6171,6 +6175,10 @@
             <a:prstDash val="solid"/>
           </a:ln>
         </p:spPr>
+        <p:txBody>
+          <a:bodyPr/>
+          <a:p/>
+        </p:txBody>
       </p:sp>
       <p:sp>
         <p:nvSpPr>
@@ -6198,6 +6206,10 @@
             <a:prstDash val="solid"/>
           </a:ln>
         </p:spPr>
+        <p:txBody>
+          <a:bodyPr/>
+          <a:p/>
+        </p:txBody>
       </p:sp>
       <p:sp>
         <p:nvSpPr>
@@ -6401,6 +6413,10 @@
             <a:prstDash val="solid"/>
           </a:ln>
         </p:spPr>
+        <p:txBody>
+          <a:bodyPr/>
+          <a:p/>
+        </p:txBody>
       </p:sp>
       <p:pic>
         <p:nvPicPr>
@@ -6527,6 +6543,10 @@
             <a:prstDash val="solid"/>
           </a:ln>
         </p:spPr>
+        <p:txBody>
+          <a:bodyPr/>
+          <a:p/>
+        </p:txBody>
       </p:sp>
       <p:pic>
         <p:nvPicPr>
@@ -6653,6 +6673,10 @@
             <a:prstDash val="solid"/>
           </a:ln>
         </p:spPr>
+        <p:txBody>
+          <a:bodyPr/>
+          <a:p/>
+        </p:txBody>
       </p:sp>
       <p:pic>
         <p:nvPicPr>
@@ -6975,6 +6999,10 @@
             <a:prstDash val="solid"/>
           </a:ln>
         </p:spPr>
+        <p:txBody>
+          <a:bodyPr/>
+          <a:p/>
+        </p:txBody>
       </p:sp>
       <p:sp>
         <p:nvSpPr>
@@ -7111,6 +7139,10 @@
             <a:prstDash val="solid"/>
           </a:ln>
         </p:spPr>
+        <p:txBody>
+          <a:bodyPr/>
+          <a:p/>
+        </p:txBody>
       </p:sp>
       <p:sp>
         <p:nvSpPr>
@@ -7247,6 +7279,10 @@
             <a:prstDash val="solid"/>
           </a:ln>
         </p:spPr>
+        <p:txBody>
+          <a:bodyPr/>
+          <a:p/>
+        </p:txBody>
       </p:sp>
       <p:sp>
         <p:nvSpPr>
@@ -7422,6 +7458,10 @@
             <a:prstDash val="solid"/>
           </a:ln>
         </p:spPr>
+        <p:txBody>
+          <a:bodyPr/>
+          <a:p/>
+        </p:txBody>
       </p:sp>
       <p:sp>
         <p:nvSpPr>
@@ -7519,6 +7559,10 @@
             <a:prstDash val="solid"/>
           </a:ln>
         </p:spPr>
+        <p:txBody>
+          <a:bodyPr/>
+          <a:p/>
+        </p:txBody>
       </p:sp>
       <p:sp>
         <p:nvSpPr>
@@ -7616,6 +7660,10 @@
             <a:prstDash val="solid"/>
           </a:ln>
         </p:spPr>
+        <p:txBody>
+          <a:bodyPr/>
+          <a:p/>
+        </p:txBody>
       </p:sp>
       <p:sp>
         <p:nvSpPr>
@@ -7713,6 +7761,10 @@
             <a:prstDash val="solid"/>
           </a:ln>
         </p:spPr>
+        <p:txBody>
+          <a:bodyPr/>
+          <a:p/>
+        </p:txBody>
       </p:sp>
       <p:sp>
         <p:nvSpPr>
@@ -7990,6 +8042,10 @@
             <a:prstDash val="solid"/>
           </a:ln>
         </p:spPr>
+        <p:txBody>
+          <a:bodyPr/>
+          <a:p/>
+        </p:txBody>
       </p:sp>
       <p:pic>
         <p:nvPicPr>
@@ -8114,6 +8170,10 @@
             <a:prstDash val="solid"/>
           </a:ln>
         </p:spPr>
+        <p:txBody>
+          <a:bodyPr/>
+          <a:p/>
+        </p:txBody>
       </p:sp>
       <p:pic>
         <p:nvPicPr>
@@ -8238,6 +8298,10 @@
             <a:prstDash val="solid"/>
           </a:ln>
         </p:spPr>
+        <p:txBody>
+          <a:bodyPr/>
+          <a:p/>
+        </p:txBody>
       </p:sp>
       <p:pic>
         <p:nvPicPr>
@@ -8362,6 +8426,10 @@
             <a:prstDash val="solid"/>
           </a:ln>
         </p:spPr>
+        <p:txBody>
+          <a:bodyPr/>
+          <a:p/>
+        </p:txBody>
       </p:sp>
       <p:sp>
         <p:nvSpPr>
@@ -8664,6 +8732,10 @@
             <a:prstDash val="solid"/>
           </a:ln>
         </p:spPr>
+        <p:txBody>
+          <a:bodyPr/>
+          <a:p/>
+        </p:txBody>
       </p:sp>
       <p:sp>
         <p:nvSpPr>
@@ -8800,6 +8872,10 @@
             <a:prstDash val="solid"/>
           </a:ln>
         </p:spPr>
+        <p:txBody>
+          <a:bodyPr/>
+          <a:p/>
+        </p:txBody>
       </p:sp>
       <p:sp>
         <p:nvSpPr>
@@ -8936,6 +9012,10 @@
             <a:prstDash val="solid"/>
           </a:ln>
         </p:spPr>
+        <p:txBody>
+          <a:bodyPr/>
+          <a:p/>
+        </p:txBody>
       </p:sp>
       <p:sp>
         <p:nvSpPr>
@@ -9294,7 +9374,7 @@
                   <a:schemeClr val="tx1"/>
                 </a:solidFill>
               </a:rPr>
-              <a:t>0.2 seconds per evaluation  </a:t>
+              <a:t>Under a second per evaluation  </a:t>
             </a:r>
             <a:pPr indent="0" marL="0">
               <a:buNone/>
@@ -9335,6 +9415,10 @@
             <a:prstDash val="solid"/>
           </a:ln>
         </p:spPr>
+        <p:txBody>
+          <a:bodyPr/>
+          <a:p/>
+        </p:txBody>
       </p:sp>
       <p:sp>
         <p:nvSpPr>
@@ -9360,6 +9444,10 @@
             <a:prstDash val="solid"/>
           </a:ln>
         </p:spPr>
+        <p:txBody>
+          <a:bodyPr/>
+          <a:p/>
+        </p:txBody>
       </p:sp>
       <p:pic>
         <p:nvPicPr>
@@ -10894,42 +10982,6 @@
                 </a:solidFill>
               </a:rPr>
               <a:t>This run: a Claude Code agent following program.md. OpenEvolve or LoongFlow drop in via one driver calling the same command.</a:t>
-            </a:r>
-            <a:endParaRPr lang="en-US" sz="1000" dirty="0"/>
-          </a:p>
-        </p:txBody>
-      </p:sp>
-      <p:sp>
-        <p:nvSpPr>
-          <p:cNvPr id="41" name="placeholder note"/>
-          <p:cNvSpPr txBox="1"/>
-          <p:nvPr/>
-        </p:nvSpPr>
-        <p:spPr>
-          <a:xfrm>
-            <a:off x="457200" y="4572000"/>
-            <a:ext cx="5120640" cy="182880"/>
-          </a:xfrm>
-          <a:prstGeom prst="rect">
-            <a:avLst/>
-          </a:prstGeom>
-          <a:noFill/>
-          <a:ln/>
-        </p:spPr>
-        <p:txBody>
-          <a:bodyPr wrap="square" lIns="0" tIns="0" rIns="0" bIns="0" rtlCol="0" anchor="ctr"/>
-          <a:lstStyle/>
-          <a:p>
-            <a:pPr indent="0" marL="0">
-              <a:buNone/>
-            </a:pPr>
-            <a:r>
-              <a:rPr lang="en-US" sz="1000" i="1" dirty="0">
-                <a:solidFill>
-                  <a:schemeClr val="accent4"/>
-                </a:solidFill>
-              </a:rPr>
-              <a:t>249 experiments logged in loop_log.md, 39 kept; every kept change is a git commit</a:t>
             </a:r>
             <a:endParaRPr lang="en-US" sz="1000" dirty="0"/>
           </a:p>
@@ -13997,7 +14049,7 @@
                   <a:schemeClr val="tx2"/>
                 </a:solidFill>
               </a:rPr>
-              <a:t>val and test were 2 to 3× more volatile than train; % of perfect tracks that</a:t>
+              <a:t>daily price spread 1.4× and 1.7× train's, ceiling 1.8× and 2.3×; % of perfect tracks that</a:t>
             </a:r>
             <a:endParaRPr lang="en-US" sz="950" dirty="0"/>
           </a:p>
@@ -14135,6 +14187,10 @@
             <a:prstDash val="solid"/>
           </a:ln>
         </p:spPr>
+        <p:txBody>
+          <a:bodyPr/>
+          <a:p/>
+        </p:txBody>
       </p:sp>
       <p:sp>
         <p:nvSpPr>
@@ -14160,6 +14216,10 @@
             <a:prstDash val="solid"/>
           </a:ln>
         </p:spPr>
+        <p:txBody>
+          <a:bodyPr/>
+          <a:p/>
+        </p:txBody>
       </p:sp>
       <p:sp>
         <p:nvSpPr>
@@ -14221,6 +14281,10 @@
             <a:prstDash val="solid"/>
           </a:ln>
         </p:spPr>
+        <p:txBody>
+          <a:bodyPr/>
+          <a:p/>
+        </p:txBody>
       </p:sp>
       <p:sp>
         <p:nvSpPr>
@@ -14472,6 +14536,10 @@
             <a:prstDash val="solid"/>
           </a:ln>
         </p:spPr>
+        <p:txBody>
+          <a:bodyPr/>
+          <a:p/>
+        </p:txBody>
       </p:sp>
       <p:pic>
         <p:nvPicPr>
@@ -14598,6 +14666,10 @@
             <a:prstDash val="solid"/>
           </a:ln>
         </p:spPr>
+        <p:txBody>
+          <a:bodyPr/>
+          <a:p/>
+        </p:txBody>
       </p:sp>
       <p:pic>
         <p:nvPicPr>
@@ -14724,6 +14796,10 @@
             <a:prstDash val="solid"/>
           </a:ln>
         </p:spPr>
+        <p:txBody>
+          <a:bodyPr/>
+          <a:p/>
+        </p:txBody>
       </p:sp>
       <p:pic>
         <p:nvPicPr>
@@ -14850,6 +14926,10 @@
             <a:prstDash val="solid"/>
           </a:ln>
         </p:spPr>
+        <p:txBody>
+          <a:bodyPr/>
+          <a:p/>
+        </p:txBody>
       </p:sp>
       <p:pic>
         <p:nvPicPr>
@@ -14974,6 +15054,10 @@
             <a:prstDash val="solid"/>
           </a:ln>
         </p:spPr>
+        <p:txBody>
+          <a:bodyPr/>
+          <a:p/>
+        </p:txBody>
       </p:sp>
       <p:pic>
         <p:nvPicPr>
@@ -15098,6 +15182,10 @@
             <a:prstDash val="solid"/>
           </a:ln>
         </p:spPr>
+        <p:txBody>
+          <a:bodyPr/>
+          <a:p/>
+        </p:txBody>
       </p:sp>
       <p:sp>
         <p:nvSpPr>
@@ -15320,7 +15408,7 @@
                   <a:schemeClr val="tx2"/>
                 </a:solidFill>
               </a:rPr>
-              <a:t>0.2 s per evaluation; the LLM is the only expense, bounded by iteration count</a:t>
+              <a:t>under a second per evaluation; the LLM is the only expense, bounded by iteration count</a:t>
             </a:r>
             <a:endParaRPr lang="en-US" sz="1100" dirty="0"/>
           </a:p>
@@ -15458,6 +15546,10 @@
             <a:prstDash val="solid"/>
           </a:ln>
         </p:spPr>
+        <p:txBody>
+          <a:bodyPr/>
+          <a:p/>
+        </p:txBody>
       </p:sp>
       <p:sp>
         <p:nvSpPr>
@@ -15483,6 +15575,10 @@
             <a:prstDash val="solid"/>
           </a:ln>
         </p:spPr>
+        <p:txBody>
+          <a:bodyPr/>
+          <a:p/>
+        </p:txBody>
       </p:sp>
       <p:pic>
         <p:nvPicPr>
@@ -15607,6 +15703,10 @@
             <a:prstDash val="solid"/>
           </a:ln>
         </p:spPr>
+        <p:txBody>
+          <a:bodyPr/>
+          <a:p/>
+        </p:txBody>
       </p:sp>
       <p:sp>
         <p:nvSpPr>
@@ -15632,6 +15732,10 @@
             <a:prstDash val="solid"/>
           </a:ln>
         </p:spPr>
+        <p:txBody>
+          <a:bodyPr/>
+          <a:p/>
+        </p:txBody>
       </p:sp>
       <p:pic>
         <p:nvPicPr>
@@ -15756,6 +15860,10 @@
             <a:prstDash val="solid"/>
           </a:ln>
         </p:spPr>
+        <p:txBody>
+          <a:bodyPr/>
+          <a:p/>
+        </p:txBody>
       </p:sp>
       <p:sp>
         <p:nvSpPr>
@@ -15781,6 +15889,10 @@
             <a:prstDash val="solid"/>
           </a:ln>
         </p:spPr>
+        <p:txBody>
+          <a:bodyPr/>
+          <a:p/>
+        </p:txBody>
       </p:sp>
       <p:pic>
         <p:nvPicPr>
@@ -15905,6 +16017,10 @@
             <a:prstDash val="solid"/>
           </a:ln>
         </p:spPr>
+        <p:txBody>
+          <a:bodyPr/>
+          <a:p/>
+        </p:txBody>
       </p:sp>
       <p:sp>
         <p:nvSpPr>
@@ -15930,6 +16046,10 @@
             <a:prstDash val="solid"/>
           </a:ln>
         </p:spPr>
+        <p:txBody>
+          <a:bodyPr/>
+          <a:p/>
+        </p:txBody>
       </p:sp>
       <p:pic>
         <p:nvPicPr>
@@ -16054,6 +16174,10 @@
             <a:prstDash val="solid"/>
           </a:ln>
         </p:spPr>
+        <p:txBody>
+          <a:bodyPr/>
+          <a:p/>
+        </p:txBody>
       </p:sp>
       <p:sp>
         <p:nvSpPr>
@@ -16079,6 +16203,10 @@
             <a:prstDash val="solid"/>
           </a:ln>
         </p:spPr>
+        <p:txBody>
+          <a:bodyPr/>
+          <a:p/>
+        </p:txBody>
       </p:sp>
       <p:pic>
         <p:nvPicPr>
@@ -16203,6 +16331,10 @@
             <a:prstDash val="solid"/>
           </a:ln>
         </p:spPr>
+        <p:txBody>
+          <a:bodyPr/>
+          <a:p/>
+        </p:txBody>
       </p:sp>
       <p:sp>
         <p:nvSpPr>
@@ -16228,6 +16360,10 @@
             <a:prstDash val="solid"/>
           </a:ln>
         </p:spPr>
+        <p:txBody>
+          <a:bodyPr/>
+          <a:p/>
+        </p:txBody>
       </p:sp>
       <p:pic>
         <p:nvPicPr>

</xml_diff>